<commit_message>
Review 3 eve: speech-driven officer page, audit log, decoder-brake sweep (6g, negative), PROJECT_CONTEXT handoff
- index.html: microphone recording (MediaRecorder) and audio upload -> /v1/complaint/audio
- app.py: sync audio handler, MIME/suffix allowlist (415), 25 MB cap (413), graph lock, FIR_PREWARM=1
- serving/audit.py: append-only JSONL of every draft (hashes, never text); /v1/health audit_entries
- WhisperAsr: repetition_penalty / no_repeat_ngram_size knobs; 60-clip sweep rejected them (finding 6g)
- run_asr_baseline: --model, --repetition-penalty, --no-repeat-ngram-size, --files
- PROJECT_CONTEXT.md: long-form handoff for teammates and LLMs building slides
- tests: 376 pass (webm/opus decode via PyAV, 415/413/400, audit log)
</commit_message>
<xml_diff>
--- a/Review3_Presentation.pptx
+++ b/Review3_Presentation.pptx
@@ -4300,7 +4300,7 @@
               </a:spcAft>
             </a:pPr>
             <a:r>
-              <a:rPr sz="1150" b="1">
+              <a:rPr sz="1100" b="1">
                 <a:solidFill>
                   <a:srgbClr val="24405B"/>
                 </a:solidFill>
@@ -4316,7 +4316,7 @@
               </a:spcAft>
             </a:pPr>
             <a:r>
-              <a:rPr sz="1150" b="0">
+              <a:rPr sz="1100" b="0">
                 <a:solidFill>
                   <a:srgbClr val="1F2A37"/>
                 </a:solidFill>
@@ -4332,7 +4332,7 @@
               </a:spcAft>
             </a:pPr>
             <a:r>
-              <a:rPr sz="1150" b="0">
+              <a:rPr sz="1100" b="0">
                 <a:solidFill>
                   <a:srgbClr val="1F2A37"/>
                 </a:solidFill>
@@ -4348,7 +4348,7 @@
               </a:spcAft>
             </a:pPr>
             <a:r>
-              <a:rPr sz="1150" b="0">
+              <a:rPr sz="1100" b="0">
                 <a:solidFill>
                   <a:srgbClr val="1F2A37"/>
                 </a:solidFill>
@@ -4364,7 +4364,7 @@
               </a:spcAft>
             </a:pPr>
             <a:r>
-              <a:rPr sz="1150" b="0">
+              <a:rPr sz="1100" b="0">
                 <a:solidFill>
                   <a:srgbClr val="1F2A37"/>
                 </a:solidFill>
@@ -4380,7 +4380,7 @@
               </a:spcAft>
             </a:pPr>
             <a:r>
-              <a:rPr sz="1150" b="1">
+              <a:rPr sz="1100" b="1">
                 <a:solidFill>
                   <a:srgbClr val="24405B"/>
                 </a:solidFill>
@@ -4396,13 +4396,29 @@
               </a:spcAft>
             </a:pPr>
             <a:r>
-              <a:rPr sz="1150" b="0">
+              <a:rPr sz="1100" b="0">
                 <a:solidFill>
                   <a:srgbClr val="1F2A37"/>
                 </a:solidFill>
                 <a:latin typeface="Calibri"/>
               </a:rPr>
-              <a:t>–  FastAPI on 127.0.0.1: /v1/complaint/{text,audio}, /v1/statute/{section}, /v1/health; a static officer page: route, sections with BNS text and element checks, “also consider”, flags, annotated form; “Mark verified” disabled by design</a:t>
+              <a:t>–  FastAPI on 127.0.0.1: /v1/complaint/{text,audio}, /v1/statute/{section}, /v1/health; the officer page records from the microphone or takes an audio file, or typed text: route, sections with BNS text and element checks, “also consider”, flags, annotated form; “Mark verified” disabled by design</a:t>
+            </a:r>
+          </a:p>
+          <a:p>
+            <a:pPr>
+              <a:spcAft>
+                <a:spcPts val="400"/>
+              </a:spcAft>
+            </a:pPr>
+            <a:r>
+              <a:rPr sz="1100" b="0">
+                <a:solidFill>
+                  <a:srgbClr val="1F2A37"/>
+                </a:solidFill>
+                <a:latin typeface="Calibri"/>
+              </a:rPr>
+              <a:t>–  Audit log v0 (P5.3): every draft appended to an immutable JSONL — record id, route, sections, flags, a hash of the text; never the text or the audio</a:t>
             </a:r>
           </a:p>
         </p:txBody>
@@ -4488,7 +4504,7 @@
                 </a:solidFill>
                 <a:latin typeface="Calibri"/>
               </a:rPr>
-              <a:t>Live demo (5 min)</a:t>
+              <a:t>Live demo (6 min)</a:t>
             </a:r>
           </a:p>
         </p:txBody>
@@ -4521,13 +4537,13 @@
               </a:spcAft>
             </a:pPr>
             <a:r>
-              <a:rPr sz="1150" b="0">
+              <a:rPr sz="1100" b="0">
                 <a:solidFill>
                   <a:srgbClr val="1F2A37"/>
                 </a:solidFill>
                 <a:latin typeface="Calibri"/>
               </a:rPr>
-              <a:t>–  1  Typed theft complaint with a value → FIR route, BNS 303(2) with the ₹5,000 proviso shown</a:t>
+              <a:t>–  1  Typed theft complaint with a value → officer review with BNS 303(2) cognizable (₹15,000 &gt; ₹5,000)</a:t>
             </a:r>
           </a:p>
           <a:p>
@@ -4537,13 +4553,13 @@
               </a:spcAft>
             </a:pPr>
             <a:r>
-              <a:rPr sz="1150" b="0">
+              <a:rPr sz="1100" b="0">
                 <a:solidFill>
                   <a:srgbClr val="1F2A37"/>
                 </a:solidFill>
                 <a:latin typeface="Calibri"/>
               </a:rPr>
-              <a:t>–  2  Same complaint without the value → officer review: “cognizability depends on property value”</a:t>
+              <a:t>–  2  Same complaint without the value → “cognizability depends on property value”; nothing defaults</a:t>
             </a:r>
           </a:p>
           <a:p>
@@ -4553,13 +4569,13 @@
               </a:spcAft>
             </a:pPr>
             <a:r>
-              <a:rPr sz="1150" b="0">
+              <a:rPr sz="1100" b="0">
                 <a:solidFill>
                   <a:srgbClr val="1F2A37"/>
                 </a:solidFill>
                 <a:latin typeface="Calibri"/>
               </a:rPr>
-              <a:t>–  3  Tamil dowry-cruelty complaint → translation loses “dowry”; the cue scan still raises IPC 498A</a:t>
+              <a:t>–  3  Dowry-cruelty complaint → FIR via BNS 80; BNS 85 conditional; element checks with quoted words</a:t>
             </a:r>
           </a:p>
           <a:p>
@@ -4569,13 +4585,13 @@
               </a:spcAft>
             </a:pPr>
             <a:r>
-              <a:rPr sz="1150" b="0">
+              <a:rPr sz="1100" b="0">
                 <a:solidFill>
                   <a:srgbClr val="1F2A37"/>
                 </a:solidFill>
                 <a:latin typeface="Calibri"/>
               </a:rPr>
-              <a:t>–  4  Look up BNS 85 → gazette text + the Schedule's condition</a:t>
+              <a:t>–  4  ● Record a Tamil complaint into the microphone → transcript, ITN (₹50,000), the same decision — speech-driven, all local</a:t>
             </a:r>
           </a:p>
           <a:p>
@@ -4585,13 +4601,13 @@
               </a:spcAft>
             </a:pPr>
             <a:r>
-              <a:rPr sz="1150" b="0">
+              <a:rPr sz="1100" b="0">
                 <a:solidFill>
                   <a:srgbClr val="1F2A37"/>
                 </a:solidFill>
                 <a:latin typeface="Calibri"/>
               </a:rPr>
-              <a:t>–  5  Spoken Tamil clip → transcript with ITN, guards, then the same path</a:t>
+              <a:t>–  5  Upload FLEURS clip 1916 → the transcript guard fires; the draft is marked not auto-resolvable</a:t>
             </a:r>
           </a:p>
           <a:p>
@@ -4601,7 +4617,23 @@
               </a:spcAft>
             </a:pPr>
             <a:r>
-              <a:rPr sz="1150" b="0">
+              <a:rPr sz="1100" b="0">
+                <a:solidFill>
+                  <a:srgbClr val="1F2A37"/>
+                </a:solidFill>
+                <a:latin typeface="Calibri"/>
+              </a:rPr>
+              <a:t>–  6  Look up BNS 85 → gazette text + the Schedule's condition</a:t>
+            </a:r>
+          </a:p>
+          <a:p>
+            <a:pPr>
+              <a:spcAft>
+                <a:spcPts val="400"/>
+              </a:spcAft>
+            </a:pPr>
+            <a:r>
+              <a:rPr sz="1100" b="0">
                 <a:solidFill>
                   <a:srgbClr val="5B6470"/>
                 </a:solidFill>
@@ -6102,7 +6134,7 @@
                           </a:solidFill>
                           <a:latin typeface="Calibri"/>
                         </a:rPr>
-                        <a:t>17 files</a:t>
+                        <a:t>18 files</a:t>
                       </a:r>
                     </a:p>
                   </a:txBody>
@@ -6146,7 +6178,7 @@
                           </a:solidFill>
                           <a:latin typeface="Calibri"/>
                         </a:rPr>
-                        <a:t>368</a:t>
+                        <a:t>376</a:t>
                       </a:r>
                     </a:p>
                   </a:txBody>
@@ -6391,7 +6423,7 @@
         </p:nvGraphicFramePr>
         <p:xfrm>
           <a:off x="640080" y="1463040"/>
-          <a:ext cx="9875520" cy="4114800"/>
+          <a:ext cx="9875520" cy="4206240"/>
         </p:xfrm>
         <a:graphic>
           <a:graphicData uri="http://schemas.openxmlformats.org/drawingml/2006/table">
@@ -6404,14 +6436,14 @@
                 <a:gridCol w="3017520"/>
                 <a:gridCol w="3840480"/>
               </a:tblGrid>
-              <a:tr h="457200">
-                <a:tc>
-                  <a:txBody>
-                    <a:bodyPr wrap="square"/>
-                    <a:lstStyle/>
-                    <a:p>
-                      <a:r>
-                        <a:rPr sz="1050" b="1">
+              <a:tr h="420624">
+                <a:tc>
+                  <a:txBody>
+                    <a:bodyPr wrap="square"/>
+                    <a:lstStyle/>
+                    <a:p>
+                      <a:r>
+                        <a:rPr sz="1000" b="1">
                           <a:solidFill>
                             <a:srgbClr val="FFFFFF"/>
                           </a:solidFill>
@@ -6433,7 +6465,7 @@
                     <a:lstStyle/>
                     <a:p>
                       <a:r>
-                        <a:rPr sz="1050" b="1">
+                        <a:rPr sz="1000" b="1">
                           <a:solidFill>
                             <a:srgbClr val="FFFFFF"/>
                           </a:solidFill>
@@ -6455,7 +6487,7 @@
                     <a:lstStyle/>
                     <a:p>
                       <a:r>
-                        <a:rPr sz="1050" b="1">
+                        <a:rPr sz="1000" b="1">
                           <a:solidFill>
                             <a:srgbClr val="FFFFFF"/>
                           </a:solidFill>
@@ -6472,14 +6504,14 @@
                   </a:tcPr>
                 </a:tc>
               </a:tr>
-              <a:tr h="457200">
-                <a:tc>
-                  <a:txBody>
-                    <a:bodyPr wrap="square"/>
-                    <a:lstStyle/>
-                    <a:p>
-                      <a:r>
-                        <a:rPr sz="1050">
+              <a:tr h="420624">
+                <a:tc>
+                  <a:txBody>
+                    <a:bodyPr wrap="square"/>
+                    <a:lstStyle/>
+                    <a:p>
+                      <a:r>
+                        <a:rPr sz="1000">
                           <a:solidFill>
                             <a:srgbClr val="1F2A37"/>
                           </a:solidFill>
@@ -6501,7 +6533,7 @@
                     <a:lstStyle/>
                     <a:p>
                       <a:r>
-                        <a:rPr sz="1050">
+                        <a:rPr sz="1000">
                           <a:solidFill>
                             <a:srgbClr val="1F2A37"/>
                           </a:solidFill>
@@ -6523,7 +6555,7 @@
                     <a:lstStyle/>
                     <a:p>
                       <a:r>
-                        <a:rPr sz="1050">
+                        <a:rPr sz="1000">
                           <a:solidFill>
                             <a:srgbClr val="1F2A37"/>
                           </a:solidFill>
@@ -6540,14 +6572,14 @@
                   </a:tcPr>
                 </a:tc>
               </a:tr>
-              <a:tr h="457200">
-                <a:tc>
-                  <a:txBody>
-                    <a:bodyPr wrap="square"/>
-                    <a:lstStyle/>
-                    <a:p>
-                      <a:r>
-                        <a:rPr sz="1050">
+              <a:tr h="420624">
+                <a:tc>
+                  <a:txBody>
+                    <a:bodyPr wrap="square"/>
+                    <a:lstStyle/>
+                    <a:p>
+                      <a:r>
+                        <a:rPr sz="1000">
                           <a:solidFill>
                             <a:srgbClr val="1F2A37"/>
                           </a:solidFill>
@@ -6569,7 +6601,7 @@
                     <a:lstStyle/>
                     <a:p>
                       <a:r>
-                        <a:rPr sz="1050">
+                        <a:rPr sz="1000">
                           <a:solidFill>
                             <a:srgbClr val="1F2A37"/>
                           </a:solidFill>
@@ -6591,7 +6623,7 @@
                     <a:lstStyle/>
                     <a:p>
                       <a:r>
-                        <a:rPr sz="1050">
+                        <a:rPr sz="1000">
                           <a:solidFill>
                             <a:srgbClr val="1F2A37"/>
                           </a:solidFill>
@@ -6608,14 +6640,14 @@
                   </a:tcPr>
                 </a:tc>
               </a:tr>
-              <a:tr h="457200">
-                <a:tc>
-                  <a:txBody>
-                    <a:bodyPr wrap="square"/>
-                    <a:lstStyle/>
-                    <a:p>
-                      <a:r>
-                        <a:rPr sz="1050">
+              <a:tr h="420624">
+                <a:tc>
+                  <a:txBody>
+                    <a:bodyPr wrap="square"/>
+                    <a:lstStyle/>
+                    <a:p>
+                      <a:r>
+                        <a:rPr sz="1000">
                           <a:solidFill>
                             <a:srgbClr val="1F2A37"/>
                           </a:solidFill>
@@ -6637,7 +6669,7 @@
                     <a:lstStyle/>
                     <a:p>
                       <a:r>
-                        <a:rPr sz="1050">
+                        <a:rPr sz="1000">
                           <a:solidFill>
                             <a:srgbClr val="1F2A37"/>
                           </a:solidFill>
@@ -6659,7 +6691,7 @@
                     <a:lstStyle/>
                     <a:p>
                       <a:r>
-                        <a:rPr sz="1050">
+                        <a:rPr sz="1000">
                           <a:solidFill>
                             <a:srgbClr val="1F2A37"/>
                           </a:solidFill>
@@ -6676,14 +6708,14 @@
                   </a:tcPr>
                 </a:tc>
               </a:tr>
-              <a:tr h="457200">
-                <a:tc>
-                  <a:txBody>
-                    <a:bodyPr wrap="square"/>
-                    <a:lstStyle/>
-                    <a:p>
-                      <a:r>
-                        <a:rPr sz="1050">
+              <a:tr h="420624">
+                <a:tc>
+                  <a:txBody>
+                    <a:bodyPr wrap="square"/>
+                    <a:lstStyle/>
+                    <a:p>
+                      <a:r>
+                        <a:rPr sz="1000">
                           <a:solidFill>
                             <a:srgbClr val="1F2A37"/>
                           </a:solidFill>
@@ -6705,7 +6737,7 @@
                     <a:lstStyle/>
                     <a:p>
                       <a:r>
-                        <a:rPr sz="1050">
+                        <a:rPr sz="1000">
                           <a:solidFill>
                             <a:srgbClr val="1F2A37"/>
                           </a:solidFill>
@@ -6727,7 +6759,7 @@
                     <a:lstStyle/>
                     <a:p>
                       <a:r>
-                        <a:rPr sz="1050">
+                        <a:rPr sz="1000">
                           <a:solidFill>
                             <a:srgbClr val="1F2A37"/>
                           </a:solidFill>
@@ -6744,14 +6776,14 @@
                   </a:tcPr>
                 </a:tc>
               </a:tr>
-              <a:tr h="457200">
-                <a:tc>
-                  <a:txBody>
-                    <a:bodyPr wrap="square"/>
-                    <a:lstStyle/>
-                    <a:p>
-                      <a:r>
-                        <a:rPr sz="1050">
+              <a:tr h="420624">
+                <a:tc>
+                  <a:txBody>
+                    <a:bodyPr wrap="square"/>
+                    <a:lstStyle/>
+                    <a:p>
+                      <a:r>
+                        <a:rPr sz="1000">
                           <a:solidFill>
                             <a:srgbClr val="1F2A37"/>
                           </a:solidFill>
@@ -6773,7 +6805,7 @@
                     <a:lstStyle/>
                     <a:p>
                       <a:r>
-                        <a:rPr sz="1050">
+                        <a:rPr sz="1000">
                           <a:solidFill>
                             <a:srgbClr val="1F2A37"/>
                           </a:solidFill>
@@ -6795,7 +6827,7 @@
                     <a:lstStyle/>
                     <a:p>
                       <a:r>
-                        <a:rPr sz="1050">
+                        <a:rPr sz="1000">
                           <a:solidFill>
                             <a:srgbClr val="1F2A37"/>
                           </a:solidFill>
@@ -6812,14 +6844,14 @@
                   </a:tcPr>
                 </a:tc>
               </a:tr>
-              <a:tr h="457200">
-                <a:tc>
-                  <a:txBody>
-                    <a:bodyPr wrap="square"/>
-                    <a:lstStyle/>
-                    <a:p>
-                      <a:r>
-                        <a:rPr sz="1050">
+              <a:tr h="420624">
+                <a:tc>
+                  <a:txBody>
+                    <a:bodyPr wrap="square"/>
+                    <a:lstStyle/>
+                    <a:p>
+                      <a:r>
+                        <a:rPr sz="1000">
                           <a:solidFill>
                             <a:srgbClr val="1F2A37"/>
                           </a:solidFill>
@@ -6841,7 +6873,7 @@
                     <a:lstStyle/>
                     <a:p>
                       <a:r>
-                        <a:rPr sz="1050">
+                        <a:rPr sz="1000">
                           <a:solidFill>
                             <a:srgbClr val="1F2A37"/>
                           </a:solidFill>
@@ -6863,7 +6895,7 @@
                     <a:lstStyle/>
                     <a:p>
                       <a:r>
-                        <a:rPr sz="1050">
+                        <a:rPr sz="1000">
                           <a:solidFill>
                             <a:srgbClr val="1F2A37"/>
                           </a:solidFill>
@@ -6880,14 +6912,14 @@
                   </a:tcPr>
                 </a:tc>
               </a:tr>
-              <a:tr h="457200">
-                <a:tc>
-                  <a:txBody>
-                    <a:bodyPr wrap="square"/>
-                    <a:lstStyle/>
-                    <a:p>
-                      <a:r>
-                        <a:rPr sz="1050">
+              <a:tr h="420624">
+                <a:tc>
+                  <a:txBody>
+                    <a:bodyPr wrap="square"/>
+                    <a:lstStyle/>
+                    <a:p>
+                      <a:r>
+                        <a:rPr sz="1000">
                           <a:solidFill>
                             <a:srgbClr val="1F2A37"/>
                           </a:solidFill>
@@ -6909,7 +6941,7 @@
                     <a:lstStyle/>
                     <a:p>
                       <a:r>
-                        <a:rPr sz="1050">
+                        <a:rPr sz="1000">
                           <a:solidFill>
                             <a:srgbClr val="1F2A37"/>
                           </a:solidFill>
@@ -6931,7 +6963,7 @@
                     <a:lstStyle/>
                     <a:p>
                       <a:r>
-                        <a:rPr sz="1050">
+                        <a:rPr sz="1000">
                           <a:solidFill>
                             <a:srgbClr val="1F2A37"/>
                           </a:solidFill>
@@ -6948,14 +6980,14 @@
                   </a:tcPr>
                 </a:tc>
               </a:tr>
-              <a:tr h="457200">
-                <a:tc>
-                  <a:txBody>
-                    <a:bodyPr wrap="square"/>
-                    <a:lstStyle/>
-                    <a:p>
-                      <a:r>
-                        <a:rPr sz="1050">
+              <a:tr h="420624">
+                <a:tc>
+                  <a:txBody>
+                    <a:bodyPr wrap="square"/>
+                    <a:lstStyle/>
+                    <a:p>
+                      <a:r>
+                        <a:rPr sz="1000">
                           <a:solidFill>
                             <a:srgbClr val="1F2A37"/>
                           </a:solidFill>
@@ -6977,7 +7009,7 @@
                     <a:lstStyle/>
                     <a:p>
                       <a:r>
-                        <a:rPr sz="1050">
+                        <a:rPr sz="1000">
                           <a:solidFill>
                             <a:srgbClr val="1F2A37"/>
                           </a:solidFill>
@@ -6999,7 +7031,7 @@
                     <a:lstStyle/>
                     <a:p>
                       <a:r>
-                        <a:rPr sz="1050">
+                        <a:rPr sz="1000">
                           <a:solidFill>
                             <a:srgbClr val="1F2A37"/>
                           </a:solidFill>
@@ -7012,6 +7044,74 @@
                   <a:tcPr marL="54864" marR="54864" marT="27432" marB="27432">
                     <a:solidFill>
                       <a:srgbClr val="F5F7F9"/>
+                    </a:solidFill>
+                  </a:tcPr>
+                </a:tc>
+              </a:tr>
+              <a:tr h="420624">
+                <a:tc>
+                  <a:txBody>
+                    <a:bodyPr wrap="square"/>
+                    <a:lstStyle/>
+                    <a:p>
+                      <a:r>
+                        <a:rPr sz="1000">
+                          <a:solidFill>
+                            <a:srgbClr val="1F2A37"/>
+                          </a:solidFill>
+                          <a:latin typeface="Calibri"/>
+                        </a:rPr>
+                        <a:t>Replay loop survives T=0 on 2/60 clips (6g)</a:t>
+                      </a:r>
+                    </a:p>
+                  </a:txBody>
+                  <a:tcPr marL="54864" marR="54864" marT="27432" marB="27432">
+                    <a:solidFill>
+                      <a:srgbClr val="FFFFFF"/>
+                    </a:solidFill>
+                  </a:tcPr>
+                </a:tc>
+                <a:tc>
+                  <a:txBody>
+                    <a:bodyPr wrap="square"/>
+                    <a:lstStyle/>
+                    <a:p>
+                      <a:r>
+                        <a:rPr sz="1000">
+                          <a:solidFill>
+                            <a:srgbClr val="1F2A37"/>
+                          </a:solidFill>
+                          <a:latin typeface="Calibri"/>
+                        </a:rPr>
+                        <a:t>sweep of 2 decoder settings on the 60 clips, day before review</a:t>
+                      </a:r>
+                    </a:p>
+                  </a:txBody>
+                  <a:tcPr marL="54864" marR="54864" marT="27432" marB="27432">
+                    <a:solidFill>
+                      <a:srgbClr val="FFFFFF"/>
+                    </a:solidFill>
+                  </a:tcPr>
+                </a:tc>
+                <a:tc>
+                  <a:txBody>
+                    <a:bodyPr wrap="square"/>
+                    <a:lstStyle/>
+                    <a:p>
+                      <a:r>
+                        <a:rPr sz="1000">
+                          <a:solidFill>
+                            <a:srgbClr val="1F2A37"/>
+                          </a:solidFill>
+                          <a:latin typeface="Calibri"/>
+                        </a:rPr>
+                        <a:t>rp 1.2, nr 0: 0 flagged, WER 57.7% vs 51.4%</a:t>
+                      </a:r>
+                    </a:p>
+                  </a:txBody>
+                  <a:tcPr marL="54864" marR="54864" marT="27432" marB="27432">
+                    <a:solidFill>
+                      <a:srgbClr val="FFFFFF"/>
                     </a:solidFill>
                   </a:tcPr>
                 </a:tc>
@@ -7268,7 +7368,7 @@
                 </a:solidFill>
                 <a:latin typeface="Calibri"/>
               </a:rPr>
-              <a:t>–  368 tests in 17 files, ~20 s, no weights: golden end-to-end fixtures, schema parity, ITN, cue battery, Schedule integrity, serving, CLI</a:t>
+              <a:t>–  376 tests in 18 files, ~20 s, no weights: golden end-to-end fixtures, schema parity, ITN, cue battery, Schedule integrity, serving, CLI</a:t>
             </a:r>
           </a:p>
           <a:p>
@@ -10443,7 +10543,7 @@
                           </a:solidFill>
                           <a:latin typeface="Calibri"/>
                         </a:rPr>
-                        <a:t>368 tests, pinned invariants, gazette-cited tables</a:t>
+                        <a:t>376 tests, pinned invariants, gazette-cited tables</a:t>
                       </a:r>
                     </a:p>
                   </a:txBody>

</xml_diff>